<commit_message>
Update lightning talk bullets to match plain-English script
Reword all 15 bullet points to align with the 1-minute spoken
script: simpler language, no product references, each bullet
maps directly to one sentence.

Co-Authored-By: Claude Sonnet 4.6 <noreply@anthropic.com>
</commit_message>
<xml_diff>
--- a/project/lightning_talk.pptx
+++ b/project/lightning_talk.pptx
@@ -3636,7 +3636,7 @@
                 </a:solidFill>
                 <a:latin typeface="Calibri"/>
               </a:rPr>
-              <a:t>Custom ASIC: 'Hey Alexa'-style KWS on a tiny IoT chip</a:t>
+              <a:t>Custom chip: hears a spoken keyword, always-on, battery-powered</a:t>
             </a:r>
           </a:p>
         </p:txBody>
@@ -3714,7 +3714,7 @@
                 </a:solidFill>
                 <a:latin typeface="Calibri"/>
               </a:rPr>
-              <a:t>Ternary weights: −1, 0, +1 only — no multipliers</a:t>
+              <a:t>Weights are only −1, 0, or +1 — no multiplication needed</a:t>
             </a:r>
           </a:p>
         </p:txBody>
@@ -3792,7 +3792,7 @@
                 </a:solidFill>
                 <a:latin typeface="Calibri"/>
               </a:rPr>
-              <a:t>10-class Google Speech Commands, &lt;1 mW always-on</a:t>
+              <a:t>Ten keywords, non-stop, under 1 mW</a:t>
             </a:r>
           </a:p>
         </p:txBody>
@@ -4155,7 +4155,7 @@
                 </a:solidFill>
                 <a:latin typeface="Calibri"/>
               </a:rPr>
-              <a:t>Prior art: PyTorch on CPU/GPU — accurate but memory-bound</a:t>
+              <a:t>Standard approach: CPU/GPU — accurate but power-hungry</a:t>
             </a:r>
           </a:p>
         </p:txBody>
@@ -4233,7 +4233,7 @@
                 </a:solidFill>
                 <a:latin typeface="Calibri"/>
               </a:rPr>
-              <a:t>BNN/TNN (Rusci 2020): XNOR+popcount on ARM Cortex-M</a:t>
+              <a:t>Others built specialized chips on ARM processors (Rusci 2020)</a:t>
             </a:r>
           </a:p>
         </p:txBody>
@@ -4311,7 +4311,7 @@
                 </a:solidFill>
                 <a:latin typeface="Calibri"/>
               </a:rPr>
-              <a:t>On-chip weight SRAM avoids DRAM bandwidth wall</a:t>
+              <a:t>Key insight: keep weights on-chip, avoid slow external memory</a:t>
             </a:r>
           </a:p>
         </p:txBody>
@@ -4674,7 +4674,7 @@
                 </a:solidFill>
                 <a:latin typeface="Calibri"/>
               </a:rPr>
-              <a:t>Arithmetic intensity: 0.50 → 406 FLOP/byte (roofline flip)</a:t>
+              <a:t>On-chip storage flips the bottleneck: memory → compute (see roofline)</a:t>
             </a:r>
           </a:p>
         </p:txBody>
@@ -4752,7 +4752,7 @@
                 </a:solidFill>
                 <a:latin typeface="Calibri"/>
               </a:rPr>
-              <a:t>Eliminates ALL multipliers — ternary MAC = pure adder tree</a:t>
+              <a:t>Weights ±1/0 replace all multipliers with add or subtract</a:t>
             </a:r>
           </a:p>
         </p:txBody>
@@ -4830,7 +4830,7 @@
                 </a:solidFill>
                 <a:latin typeface="Calibri"/>
               </a:rPr>
-              <a:t>Parametric SystemVerilog + SPI slave for drop-in MCU use</a:t>
+              <a:t>Built in SystemVerilog with SPI — plugs into any microcontroller</a:t>
             </a:r>
           </a:p>
         </p:txBody>
@@ -5193,7 +5193,7 @@
                 </a:solidFill>
                 <a:latin typeface="Calibri"/>
               </a:rPr>
-              <a:t>SW baseline: 4.91 GFLOP/s, 0.44 ms/inf, AI=0.50 confirmed</a:t>
+              <a:t>SW baseline: 0.44 ms/inference, bottlenecked by memory — confirmed</a:t>
             </a:r>
           </a:p>
         </p:txBody>
@@ -5271,7 +5271,7 @@
                 </a:solidFill>
                 <a:latin typeface="Calibri"/>
               </a:rPr>
-              <a:t>RTL done: compute_core.sv + spi_slave.sv (SPI Mode 0)</a:t>
+              <a:t>Math core + SPI interface written and working in simulation</a:t>
             </a:r>
           </a:p>
         </p:txBody>
@@ -5349,7 +5349,7 @@
                 </a:solidFill>
                 <a:latin typeface="Calibri"/>
               </a:rPr>
-              <a:t>Testbenches PASS: 4/4 MAC outputs + SPI write/read</a:t>
+              <a:t>All 4 outputs match expected values; SPI read &amp; write pass</a:t>
             </a:r>
           </a:p>
         </p:txBody>
@@ -5712,7 +5712,7 @@
                 </a:solidFill>
                 <a:latin typeface="Calibri"/>
               </a:rPr>
-              <a:t>M3: OpenLane 2 ASIC synthesis → area, power, timing</a:t>
+              <a:t>Run synthesis to get real chip area, power &amp; speed numbers</a:t>
             </a:r>
           </a:p>
         </p:txBody>
@@ -5790,7 +5790,7 @@
                 </a:solidFill>
                 <a:latin typeface="Calibri"/>
               </a:rPr>
-              <a:t>M4: HW vs SW speedup for FC1 kernel (target &gt;100×)</a:t>
+              <a:t>Compare HW vs SW performance — target more than 100× faster</a:t>
             </a:r>
           </a:p>
         </p:txBody>
@@ -5868,7 +5868,7 @@
                 </a:solidFill>
                 <a:latin typeface="Calibri"/>
               </a:rPr>
-              <a:t>Success = synthesizable, ≥92% KWS accuracy, &lt;1 mW</a:t>
+              <a:t>Success: synthesizable design, ≥92% accuracy, under 1 mW</a:t>
             </a:r>
           </a:p>
         </p:txBody>

</xml_diff>

<commit_message>
Polish lightning talk slide: remove brand name, tighten sidebar, reflow pipeline
- Replace 'hey alexa' with 'Keyword Detected!'
- Sidebar bullets reduced to 7.5pt, headers to 8.5pt, tighter spacing
- System pipeline rebalanced: wider ASIC outline, evenly spaced sub-blocks

Co-Authored-By: Claude Sonnet 4.6 <noreply@anthropic.com>
</commit_message>
<xml_diff>
--- a/project/lightning_talk.pptx
+++ b/project/lightning_talk.pptx
@@ -3373,7 +3373,7 @@
         <p:spPr>
           <a:xfrm>
             <a:off x="7552944" y="804672"/>
-            <a:ext cx="4425696" cy="292608"/>
+            <a:ext cx="4425696" cy="256032"/>
           </a:xfrm>
           <a:prstGeom prst="rect">
             <a:avLst/>
@@ -3415,8 +3415,8 @@
         </p:nvSpPr>
         <p:spPr>
           <a:xfrm>
-            <a:off x="7580375" y="841248"/>
-            <a:ext cx="201168" cy="201168"/>
+            <a:off x="7580375" y="832104"/>
+            <a:ext cx="182880" cy="182880"/>
           </a:xfrm>
           <a:prstGeom prst="ellipse">
             <a:avLst/>
@@ -3458,8 +3458,8 @@
         </p:nvSpPr>
         <p:spPr>
           <a:xfrm>
-            <a:off x="7580375" y="832104"/>
-            <a:ext cx="201168" cy="219456"/>
+            <a:off x="7580375" y="827532"/>
+            <a:ext cx="182880" cy="201168"/>
           </a:xfrm>
           <a:prstGeom prst="rect">
             <a:avLst/>
@@ -3474,7 +3474,7 @@
           <a:p>
             <a:pPr algn="ctr"/>
             <a:r>
-              <a:rPr sz="800" b="1">
+              <a:rPr sz="700" b="1">
                 <a:solidFill>
                   <a:srgbClr val="FFFFFF"/>
                 </a:solidFill>
@@ -3493,8 +3493,8 @@
         </p:nvSpPr>
         <p:spPr>
           <a:xfrm>
-            <a:off x="7827263" y="841248"/>
-            <a:ext cx="4078224" cy="237744"/>
+            <a:off x="7808975" y="832104"/>
+            <a:ext cx="4096512" cy="219456"/>
           </a:xfrm>
           <a:prstGeom prst="rect">
             <a:avLst/>
@@ -3509,7 +3509,7 @@
           <a:p>
             <a:pPr algn="l"/>
             <a:r>
-              <a:rPr sz="950" b="1">
+              <a:rPr sz="850" b="1">
                 <a:solidFill>
                   <a:srgbClr val="38BDF8"/>
                 </a:solidFill>
@@ -3528,8 +3528,8 @@
         </p:nvSpPr>
         <p:spPr>
           <a:xfrm>
-            <a:off x="7552944" y="1097280"/>
-            <a:ext cx="4425696" cy="9144"/>
+            <a:off x="7552944" y="1060704"/>
+            <a:ext cx="4425696" cy="7315"/>
           </a:xfrm>
           <a:prstGeom prst="rect">
             <a:avLst/>
@@ -3571,8 +3571,8 @@
         </p:nvSpPr>
         <p:spPr>
           <a:xfrm>
-            <a:off x="7699248" y="1152144"/>
-            <a:ext cx="68580" cy="68580"/>
+            <a:off x="7699248" y="1106424"/>
+            <a:ext cx="59436" cy="59436"/>
           </a:xfrm>
           <a:prstGeom prst="ellipse">
             <a:avLst/>
@@ -3614,8 +3614,8 @@
         </p:nvSpPr>
         <p:spPr>
           <a:xfrm>
-            <a:off x="7790688" y="1115568"/>
-            <a:ext cx="4133088" cy="260908"/>
+            <a:off x="7781544" y="1074420"/>
+            <a:ext cx="4151376" cy="283768"/>
           </a:xfrm>
           <a:prstGeom prst="rect">
             <a:avLst/>
@@ -3630,7 +3630,7 @@
           <a:p>
             <a:pPr algn="l"/>
             <a:r>
-              <a:rPr sz="800" b="0">
+              <a:rPr sz="750" b="0">
                 <a:solidFill>
                   <a:srgbClr val="CBD5E1"/>
                 </a:solidFill>
@@ -3649,8 +3649,8 @@
         </p:nvSpPr>
         <p:spPr>
           <a:xfrm>
-            <a:off x="7699248" y="1431340"/>
-            <a:ext cx="68580" cy="68580"/>
+            <a:off x="7699248" y="1399336"/>
+            <a:ext cx="59436" cy="59436"/>
           </a:xfrm>
           <a:prstGeom prst="ellipse">
             <a:avLst/>
@@ -3692,8 +3692,8 @@
         </p:nvSpPr>
         <p:spPr>
           <a:xfrm>
-            <a:off x="7790688" y="1394764"/>
-            <a:ext cx="4133088" cy="260908"/>
+            <a:off x="7781544" y="1367332"/>
+            <a:ext cx="4151376" cy="283768"/>
           </a:xfrm>
           <a:prstGeom prst="rect">
             <a:avLst/>
@@ -3708,7 +3708,7 @@
           <a:p>
             <a:pPr algn="l"/>
             <a:r>
-              <a:rPr sz="800" b="0">
+              <a:rPr sz="750" b="0">
                 <a:solidFill>
                   <a:srgbClr val="CBD5E1"/>
                 </a:solidFill>
@@ -3727,8 +3727,8 @@
         </p:nvSpPr>
         <p:spPr>
           <a:xfrm>
-            <a:off x="7699248" y="1710537"/>
-            <a:ext cx="68580" cy="68580"/>
+            <a:off x="7699248" y="1692249"/>
+            <a:ext cx="59436" cy="59436"/>
           </a:xfrm>
           <a:prstGeom prst="ellipse">
             <a:avLst/>
@@ -3770,8 +3770,8 @@
         </p:nvSpPr>
         <p:spPr>
           <a:xfrm>
-            <a:off x="7790688" y="1673961"/>
-            <a:ext cx="4133088" cy="260908"/>
+            <a:off x="7781544" y="1660245"/>
+            <a:ext cx="4151376" cy="283768"/>
           </a:xfrm>
           <a:prstGeom prst="rect">
             <a:avLst/>
@@ -3786,7 +3786,7 @@
           <a:p>
             <a:pPr algn="l"/>
             <a:r>
-              <a:rPr sz="800" b="0">
+              <a:rPr sz="750" b="0">
                 <a:solidFill>
                   <a:srgbClr val="CBD5E1"/>
                 </a:solidFill>
@@ -3892,7 +3892,7 @@
         <p:spPr>
           <a:xfrm>
             <a:off x="7552944" y="1953158"/>
-            <a:ext cx="4425696" cy="292608"/>
+            <a:ext cx="4425696" cy="256032"/>
           </a:xfrm>
           <a:prstGeom prst="rect">
             <a:avLst/>
@@ -3934,8 +3934,8 @@
         </p:nvSpPr>
         <p:spPr>
           <a:xfrm>
-            <a:off x="7580375" y="1989734"/>
-            <a:ext cx="201168" cy="201168"/>
+            <a:off x="7580375" y="1980590"/>
+            <a:ext cx="182880" cy="182880"/>
           </a:xfrm>
           <a:prstGeom prst="ellipse">
             <a:avLst/>
@@ -3977,8 +3977,8 @@
         </p:nvSpPr>
         <p:spPr>
           <a:xfrm>
-            <a:off x="7580375" y="1980590"/>
-            <a:ext cx="201168" cy="219456"/>
+            <a:off x="7580375" y="1976018"/>
+            <a:ext cx="182880" cy="201168"/>
           </a:xfrm>
           <a:prstGeom prst="rect">
             <a:avLst/>
@@ -3993,7 +3993,7 @@
           <a:p>
             <a:pPr algn="ctr"/>
             <a:r>
-              <a:rPr sz="800" b="1">
+              <a:rPr sz="700" b="1">
                 <a:solidFill>
                   <a:srgbClr val="FFFFFF"/>
                 </a:solidFill>
@@ -4012,8 +4012,8 @@
         </p:nvSpPr>
         <p:spPr>
           <a:xfrm>
-            <a:off x="7827263" y="1989734"/>
-            <a:ext cx="4078224" cy="237744"/>
+            <a:off x="7808975" y="1980590"/>
+            <a:ext cx="4096512" cy="219456"/>
           </a:xfrm>
           <a:prstGeom prst="rect">
             <a:avLst/>
@@ -4028,7 +4028,7 @@
           <a:p>
             <a:pPr algn="l"/>
             <a:r>
-              <a:rPr sz="950" b="1">
+              <a:rPr sz="850" b="1">
                 <a:solidFill>
                   <a:srgbClr val="2DD4BF"/>
                 </a:solidFill>
@@ -4047,8 +4047,8 @@
         </p:nvSpPr>
         <p:spPr>
           <a:xfrm>
-            <a:off x="7552944" y="2245766"/>
-            <a:ext cx="4425696" cy="9144"/>
+            <a:off x="7552944" y="2209190"/>
+            <a:ext cx="4425696" cy="7315"/>
           </a:xfrm>
           <a:prstGeom prst="rect">
             <a:avLst/>
@@ -4090,8 +4090,8 @@
         </p:nvSpPr>
         <p:spPr>
           <a:xfrm>
-            <a:off x="7699248" y="2300630"/>
-            <a:ext cx="68580" cy="68580"/>
+            <a:off x="7699248" y="2254910"/>
+            <a:ext cx="59436" cy="59436"/>
           </a:xfrm>
           <a:prstGeom prst="ellipse">
             <a:avLst/>
@@ -4133,8 +4133,8 @@
         </p:nvSpPr>
         <p:spPr>
           <a:xfrm>
-            <a:off x="7790688" y="2264054"/>
-            <a:ext cx="4133088" cy="260908"/>
+            <a:off x="7781544" y="2222906"/>
+            <a:ext cx="4151376" cy="283768"/>
           </a:xfrm>
           <a:prstGeom prst="rect">
             <a:avLst/>
@@ -4149,7 +4149,7 @@
           <a:p>
             <a:pPr algn="l"/>
             <a:r>
-              <a:rPr sz="800" b="0">
+              <a:rPr sz="750" b="0">
                 <a:solidFill>
                   <a:srgbClr val="CBD5E1"/>
                 </a:solidFill>
@@ -4168,8 +4168,8 @@
         </p:nvSpPr>
         <p:spPr>
           <a:xfrm>
-            <a:off x="7699248" y="2579827"/>
-            <a:ext cx="68580" cy="68580"/>
+            <a:off x="7699248" y="2547823"/>
+            <a:ext cx="59436" cy="59436"/>
           </a:xfrm>
           <a:prstGeom prst="ellipse">
             <a:avLst/>
@@ -4211,8 +4211,8 @@
         </p:nvSpPr>
         <p:spPr>
           <a:xfrm>
-            <a:off x="7790688" y="2543251"/>
-            <a:ext cx="4133088" cy="260908"/>
+            <a:off x="7781544" y="2515819"/>
+            <a:ext cx="4151376" cy="283768"/>
           </a:xfrm>
           <a:prstGeom prst="rect">
             <a:avLst/>
@@ -4227,7 +4227,7 @@
           <a:p>
             <a:pPr algn="l"/>
             <a:r>
-              <a:rPr sz="800" b="0">
+              <a:rPr sz="750" b="0">
                 <a:solidFill>
                   <a:srgbClr val="CBD5E1"/>
                 </a:solidFill>
@@ -4246,8 +4246,8 @@
         </p:nvSpPr>
         <p:spPr>
           <a:xfrm>
-            <a:off x="7699248" y="2859024"/>
-            <a:ext cx="68580" cy="68580"/>
+            <a:off x="7699248" y="2840736"/>
+            <a:ext cx="59436" cy="59436"/>
           </a:xfrm>
           <a:prstGeom prst="ellipse">
             <a:avLst/>
@@ -4289,8 +4289,8 @@
         </p:nvSpPr>
         <p:spPr>
           <a:xfrm>
-            <a:off x="7790688" y="2822448"/>
-            <a:ext cx="4133088" cy="260908"/>
+            <a:off x="7781544" y="2808732"/>
+            <a:ext cx="4151376" cy="283768"/>
           </a:xfrm>
           <a:prstGeom prst="rect">
             <a:avLst/>
@@ -4305,7 +4305,7 @@
           <a:p>
             <a:pPr algn="l"/>
             <a:r>
-              <a:rPr sz="800" b="0">
+              <a:rPr sz="750" b="0">
                 <a:solidFill>
                   <a:srgbClr val="CBD5E1"/>
                 </a:solidFill>
@@ -4411,7 +4411,7 @@
         <p:spPr>
           <a:xfrm>
             <a:off x="7552944" y="3101644"/>
-            <a:ext cx="4425696" cy="292608"/>
+            <a:ext cx="4425696" cy="256032"/>
           </a:xfrm>
           <a:prstGeom prst="rect">
             <a:avLst/>
@@ -4453,8 +4453,8 @@
         </p:nvSpPr>
         <p:spPr>
           <a:xfrm>
-            <a:off x="7580375" y="3138220"/>
-            <a:ext cx="201168" cy="201168"/>
+            <a:off x="7580375" y="3129076"/>
+            <a:ext cx="182880" cy="182880"/>
           </a:xfrm>
           <a:prstGeom prst="ellipse">
             <a:avLst/>
@@ -4496,8 +4496,8 @@
         </p:nvSpPr>
         <p:spPr>
           <a:xfrm>
-            <a:off x="7580375" y="3129076"/>
-            <a:ext cx="201168" cy="219456"/>
+            <a:off x="7580375" y="3124504"/>
+            <a:ext cx="182880" cy="201168"/>
           </a:xfrm>
           <a:prstGeom prst="rect">
             <a:avLst/>
@@ -4512,7 +4512,7 @@
           <a:p>
             <a:pPr algn="ctr"/>
             <a:r>
-              <a:rPr sz="800" b="1">
+              <a:rPr sz="700" b="1">
                 <a:solidFill>
                   <a:srgbClr val="FFFFFF"/>
                 </a:solidFill>
@@ -4531,8 +4531,8 @@
         </p:nvSpPr>
         <p:spPr>
           <a:xfrm>
-            <a:off x="7827263" y="3138220"/>
-            <a:ext cx="4078224" cy="237744"/>
+            <a:off x="7808975" y="3129076"/>
+            <a:ext cx="4096512" cy="219456"/>
           </a:xfrm>
           <a:prstGeom prst="rect">
             <a:avLst/>
@@ -4547,7 +4547,7 @@
           <a:p>
             <a:pPr algn="l"/>
             <a:r>
-              <a:rPr sz="950" b="1">
+              <a:rPr sz="850" b="1">
                 <a:solidFill>
                   <a:srgbClr val="4ADE80"/>
                 </a:solidFill>
@@ -4566,8 +4566,8 @@
         </p:nvSpPr>
         <p:spPr>
           <a:xfrm>
-            <a:off x="7552944" y="3394252"/>
-            <a:ext cx="4425696" cy="9144"/>
+            <a:off x="7552944" y="3357676"/>
+            <a:ext cx="4425696" cy="7315"/>
           </a:xfrm>
           <a:prstGeom prst="rect">
             <a:avLst/>
@@ -4609,8 +4609,8 @@
         </p:nvSpPr>
         <p:spPr>
           <a:xfrm>
-            <a:off x="7699248" y="3449116"/>
-            <a:ext cx="68580" cy="68580"/>
+            <a:off x="7699248" y="3403396"/>
+            <a:ext cx="59436" cy="59436"/>
           </a:xfrm>
           <a:prstGeom prst="ellipse">
             <a:avLst/>
@@ -4652,8 +4652,8 @@
         </p:nvSpPr>
         <p:spPr>
           <a:xfrm>
-            <a:off x="7790688" y="3412540"/>
-            <a:ext cx="4133088" cy="260908"/>
+            <a:off x="7781544" y="3371392"/>
+            <a:ext cx="4151376" cy="283768"/>
           </a:xfrm>
           <a:prstGeom prst="rect">
             <a:avLst/>
@@ -4668,7 +4668,7 @@
           <a:p>
             <a:pPr algn="l"/>
             <a:r>
-              <a:rPr sz="800" b="0">
+              <a:rPr sz="750" b="0">
                 <a:solidFill>
                   <a:srgbClr val="CBD5E1"/>
                 </a:solidFill>
@@ -4687,8 +4687,8 @@
         </p:nvSpPr>
         <p:spPr>
           <a:xfrm>
-            <a:off x="7699248" y="3728313"/>
-            <a:ext cx="68580" cy="68580"/>
+            <a:off x="7699248" y="3696309"/>
+            <a:ext cx="59436" cy="59436"/>
           </a:xfrm>
           <a:prstGeom prst="ellipse">
             <a:avLst/>
@@ -4730,8 +4730,8 @@
         </p:nvSpPr>
         <p:spPr>
           <a:xfrm>
-            <a:off x="7790688" y="3691737"/>
-            <a:ext cx="4133088" cy="260908"/>
+            <a:off x="7781544" y="3664305"/>
+            <a:ext cx="4151376" cy="283768"/>
           </a:xfrm>
           <a:prstGeom prst="rect">
             <a:avLst/>
@@ -4746,7 +4746,7 @@
           <a:p>
             <a:pPr algn="l"/>
             <a:r>
-              <a:rPr sz="800" b="0">
+              <a:rPr sz="750" b="0">
                 <a:solidFill>
                   <a:srgbClr val="CBD5E1"/>
                 </a:solidFill>
@@ -4765,8 +4765,8 @@
         </p:nvSpPr>
         <p:spPr>
           <a:xfrm>
-            <a:off x="7699248" y="4007510"/>
-            <a:ext cx="68580" cy="68580"/>
+            <a:off x="7699248" y="3989222"/>
+            <a:ext cx="59436" cy="59436"/>
           </a:xfrm>
           <a:prstGeom prst="ellipse">
             <a:avLst/>
@@ -4808,8 +4808,8 @@
         </p:nvSpPr>
         <p:spPr>
           <a:xfrm>
-            <a:off x="7790688" y="3970934"/>
-            <a:ext cx="4133088" cy="260908"/>
+            <a:off x="7781544" y="3957218"/>
+            <a:ext cx="4151376" cy="283768"/>
           </a:xfrm>
           <a:prstGeom prst="rect">
             <a:avLst/>
@@ -4824,7 +4824,7 @@
           <a:p>
             <a:pPr algn="l"/>
             <a:r>
-              <a:rPr sz="800" b="0">
+              <a:rPr sz="750" b="0">
                 <a:solidFill>
                   <a:srgbClr val="CBD5E1"/>
                 </a:solidFill>
@@ -4930,7 +4930,7 @@
         <p:spPr>
           <a:xfrm>
             <a:off x="7552944" y="4250131"/>
-            <a:ext cx="4425696" cy="292608"/>
+            <a:ext cx="4425696" cy="256032"/>
           </a:xfrm>
           <a:prstGeom prst="rect">
             <a:avLst/>
@@ -4972,8 +4972,8 @@
         </p:nvSpPr>
         <p:spPr>
           <a:xfrm>
-            <a:off x="7580375" y="4286707"/>
-            <a:ext cx="201168" cy="201168"/>
+            <a:off x="7580375" y="4277563"/>
+            <a:ext cx="182880" cy="182880"/>
           </a:xfrm>
           <a:prstGeom prst="ellipse">
             <a:avLst/>
@@ -5015,8 +5015,8 @@
         </p:nvSpPr>
         <p:spPr>
           <a:xfrm>
-            <a:off x="7580375" y="4277563"/>
-            <a:ext cx="201168" cy="219456"/>
+            <a:off x="7580375" y="4272991"/>
+            <a:ext cx="182880" cy="201168"/>
           </a:xfrm>
           <a:prstGeom prst="rect">
             <a:avLst/>
@@ -5031,7 +5031,7 @@
           <a:p>
             <a:pPr algn="ctr"/>
             <a:r>
-              <a:rPr sz="800" b="1">
+              <a:rPr sz="700" b="1">
                 <a:solidFill>
                   <a:srgbClr val="FFFFFF"/>
                 </a:solidFill>
@@ -5050,8 +5050,8 @@
         </p:nvSpPr>
         <p:spPr>
           <a:xfrm>
-            <a:off x="7827263" y="4286707"/>
-            <a:ext cx="4078224" cy="237744"/>
+            <a:off x="7808975" y="4277563"/>
+            <a:ext cx="4096512" cy="219456"/>
           </a:xfrm>
           <a:prstGeom prst="rect">
             <a:avLst/>
@@ -5066,7 +5066,7 @@
           <a:p>
             <a:pPr algn="l"/>
             <a:r>
-              <a:rPr sz="950" b="1">
+              <a:rPr sz="850" b="1">
                 <a:solidFill>
                   <a:srgbClr val="FB923C"/>
                 </a:solidFill>
@@ -5085,8 +5085,8 @@
         </p:nvSpPr>
         <p:spPr>
           <a:xfrm>
-            <a:off x="7552944" y="4542739"/>
-            <a:ext cx="4425696" cy="9144"/>
+            <a:off x="7552944" y="4506163"/>
+            <a:ext cx="4425696" cy="7315"/>
           </a:xfrm>
           <a:prstGeom prst="rect">
             <a:avLst/>
@@ -5128,8 +5128,8 @@
         </p:nvSpPr>
         <p:spPr>
           <a:xfrm>
-            <a:off x="7699248" y="4597603"/>
-            <a:ext cx="68580" cy="68580"/>
+            <a:off x="7699248" y="4551883"/>
+            <a:ext cx="59436" cy="59436"/>
           </a:xfrm>
           <a:prstGeom prst="ellipse">
             <a:avLst/>
@@ -5171,8 +5171,8 @@
         </p:nvSpPr>
         <p:spPr>
           <a:xfrm>
-            <a:off x="7790688" y="4561027"/>
-            <a:ext cx="4133088" cy="260908"/>
+            <a:off x="7781544" y="4519879"/>
+            <a:ext cx="4151376" cy="283768"/>
           </a:xfrm>
           <a:prstGeom prst="rect">
             <a:avLst/>
@@ -5187,7 +5187,7 @@
           <a:p>
             <a:pPr algn="l"/>
             <a:r>
-              <a:rPr sz="800" b="0">
+              <a:rPr sz="750" b="0">
                 <a:solidFill>
                   <a:srgbClr val="CBD5E1"/>
                 </a:solidFill>
@@ -5206,8 +5206,8 @@
         </p:nvSpPr>
         <p:spPr>
           <a:xfrm>
-            <a:off x="7699248" y="4876800"/>
-            <a:ext cx="68580" cy="68580"/>
+            <a:off x="7699248" y="4844796"/>
+            <a:ext cx="59436" cy="59436"/>
           </a:xfrm>
           <a:prstGeom prst="ellipse">
             <a:avLst/>
@@ -5249,8 +5249,8 @@
         </p:nvSpPr>
         <p:spPr>
           <a:xfrm>
-            <a:off x="7790688" y="4840224"/>
-            <a:ext cx="4133088" cy="260908"/>
+            <a:off x="7781544" y="4812791"/>
+            <a:ext cx="4151376" cy="283768"/>
           </a:xfrm>
           <a:prstGeom prst="rect">
             <a:avLst/>
@@ -5265,7 +5265,7 @@
           <a:p>
             <a:pPr algn="l"/>
             <a:r>
-              <a:rPr sz="800" b="0">
+              <a:rPr sz="750" b="0">
                 <a:solidFill>
                   <a:srgbClr val="CBD5E1"/>
                 </a:solidFill>
@@ -5284,8 +5284,8 @@
         </p:nvSpPr>
         <p:spPr>
           <a:xfrm>
-            <a:off x="7699248" y="5155996"/>
-            <a:ext cx="68580" cy="68580"/>
+            <a:off x="7699248" y="5137708"/>
+            <a:ext cx="59436" cy="59436"/>
           </a:xfrm>
           <a:prstGeom prst="ellipse">
             <a:avLst/>
@@ -5327,8 +5327,8 @@
         </p:nvSpPr>
         <p:spPr>
           <a:xfrm>
-            <a:off x="7790688" y="5119420"/>
-            <a:ext cx="4133088" cy="260908"/>
+            <a:off x="7781544" y="5105704"/>
+            <a:ext cx="4151376" cy="283768"/>
           </a:xfrm>
           <a:prstGeom prst="rect">
             <a:avLst/>
@@ -5343,7 +5343,7 @@
           <a:p>
             <a:pPr algn="l"/>
             <a:r>
-              <a:rPr sz="800" b="0">
+              <a:rPr sz="750" b="0">
                 <a:solidFill>
                   <a:srgbClr val="CBD5E1"/>
                 </a:solidFill>
@@ -5449,7 +5449,7 @@
         <p:spPr>
           <a:xfrm>
             <a:off x="7552944" y="5398617"/>
-            <a:ext cx="4425696" cy="292608"/>
+            <a:ext cx="4425696" cy="256032"/>
           </a:xfrm>
           <a:prstGeom prst="rect">
             <a:avLst/>
@@ -5491,8 +5491,8 @@
         </p:nvSpPr>
         <p:spPr>
           <a:xfrm>
-            <a:off x="7580375" y="5435193"/>
-            <a:ext cx="201168" cy="201168"/>
+            <a:off x="7580375" y="5426049"/>
+            <a:ext cx="182880" cy="182880"/>
           </a:xfrm>
           <a:prstGeom prst="ellipse">
             <a:avLst/>
@@ -5534,8 +5534,8 @@
         </p:nvSpPr>
         <p:spPr>
           <a:xfrm>
-            <a:off x="7580375" y="5426049"/>
-            <a:ext cx="201168" cy="219456"/>
+            <a:off x="7580375" y="5421477"/>
+            <a:ext cx="182880" cy="201168"/>
           </a:xfrm>
           <a:prstGeom prst="rect">
             <a:avLst/>
@@ -5550,7 +5550,7 @@
           <a:p>
             <a:pPr algn="ctr"/>
             <a:r>
-              <a:rPr sz="800" b="1">
+              <a:rPr sz="700" b="1">
                 <a:solidFill>
                   <a:srgbClr val="FFFFFF"/>
                 </a:solidFill>
@@ -5569,8 +5569,8 @@
         </p:nvSpPr>
         <p:spPr>
           <a:xfrm>
-            <a:off x="7827263" y="5435193"/>
-            <a:ext cx="4078224" cy="237744"/>
+            <a:off x="7808975" y="5426049"/>
+            <a:ext cx="4096512" cy="219456"/>
           </a:xfrm>
           <a:prstGeom prst="rect">
             <a:avLst/>
@@ -5585,7 +5585,7 @@
           <a:p>
             <a:pPr algn="l"/>
             <a:r>
-              <a:rPr sz="950" b="1">
+              <a:rPr sz="850" b="1">
                 <a:solidFill>
                   <a:srgbClr val="F87171"/>
                 </a:solidFill>
@@ -5604,8 +5604,8 @@
         </p:nvSpPr>
         <p:spPr>
           <a:xfrm>
-            <a:off x="7552944" y="5691225"/>
-            <a:ext cx="4425696" cy="9144"/>
+            <a:off x="7552944" y="5654649"/>
+            <a:ext cx="4425696" cy="7315"/>
           </a:xfrm>
           <a:prstGeom prst="rect">
             <a:avLst/>
@@ -5647,8 +5647,8 @@
         </p:nvSpPr>
         <p:spPr>
           <a:xfrm>
-            <a:off x="7699248" y="5746089"/>
-            <a:ext cx="68580" cy="68580"/>
+            <a:off x="7699248" y="5700369"/>
+            <a:ext cx="59436" cy="59436"/>
           </a:xfrm>
           <a:prstGeom prst="ellipse">
             <a:avLst/>
@@ -5690,8 +5690,8 @@
         </p:nvSpPr>
         <p:spPr>
           <a:xfrm>
-            <a:off x="7790688" y="5709513"/>
-            <a:ext cx="4133088" cy="260908"/>
+            <a:off x="7781544" y="5668365"/>
+            <a:ext cx="4151376" cy="283768"/>
           </a:xfrm>
           <a:prstGeom prst="rect">
             <a:avLst/>
@@ -5706,7 +5706,7 @@
           <a:p>
             <a:pPr algn="l"/>
             <a:r>
-              <a:rPr sz="800" b="0">
+              <a:rPr sz="750" b="0">
                 <a:solidFill>
                   <a:srgbClr val="CBD5E1"/>
                 </a:solidFill>
@@ -5725,8 +5725,8 @@
         </p:nvSpPr>
         <p:spPr>
           <a:xfrm>
-            <a:off x="7699248" y="6025286"/>
-            <a:ext cx="68580" cy="68580"/>
+            <a:off x="7699248" y="5993282"/>
+            <a:ext cx="59436" cy="59436"/>
           </a:xfrm>
           <a:prstGeom prst="ellipse">
             <a:avLst/>
@@ -5768,8 +5768,8 @@
         </p:nvSpPr>
         <p:spPr>
           <a:xfrm>
-            <a:off x="7790688" y="5988710"/>
-            <a:ext cx="4133088" cy="260908"/>
+            <a:off x="7781544" y="5961278"/>
+            <a:ext cx="4151376" cy="283768"/>
           </a:xfrm>
           <a:prstGeom prst="rect">
             <a:avLst/>
@@ -5784,7 +5784,7 @@
           <a:p>
             <a:pPr algn="l"/>
             <a:r>
-              <a:rPr sz="800" b="0">
+              <a:rPr sz="750" b="0">
                 <a:solidFill>
                   <a:srgbClr val="CBD5E1"/>
                 </a:solidFill>
@@ -5803,8 +5803,8 @@
         </p:nvSpPr>
         <p:spPr>
           <a:xfrm>
-            <a:off x="7699248" y="6304483"/>
-            <a:ext cx="68580" cy="68580"/>
+            <a:off x="7699248" y="6286195"/>
+            <a:ext cx="59436" cy="59436"/>
           </a:xfrm>
           <a:prstGeom prst="ellipse">
             <a:avLst/>
@@ -5846,8 +5846,8 @@
         </p:nvSpPr>
         <p:spPr>
           <a:xfrm>
-            <a:off x="7790688" y="6267907"/>
-            <a:ext cx="4133088" cy="260908"/>
+            <a:off x="7781544" y="6254191"/>
+            <a:ext cx="4151376" cy="283768"/>
           </a:xfrm>
           <a:prstGeom prst="rect">
             <a:avLst/>
@@ -5862,7 +5862,7 @@
           <a:p>
             <a:pPr algn="l"/>
             <a:r>
-              <a:rPr sz="800" b="0">
+              <a:rPr sz="750" b="0">
                 <a:solidFill>
                   <a:srgbClr val="CBD5E1"/>
                 </a:solidFill>

</xml_diff>

<commit_message>
Trim sidebar to 2 bullets/section for tighter 1-min talk
Co-Authored-By: Claude Sonnet 4.6 <noreply@anthropic.com>
</commit_message>
<xml_diff>
--- a/project/lightning_talk.pptx
+++ b/project/lightning_talk.pptx
@@ -3615,7 +3615,7 @@
         <p:spPr>
           <a:xfrm>
             <a:off x="7781544" y="1074420"/>
-            <a:ext cx="4151376" cy="283768"/>
+            <a:ext cx="4151376" cy="430225"/>
           </a:xfrm>
           <a:prstGeom prst="rect">
             <a:avLst/>
@@ -3649,7 +3649,7 @@
         </p:nvSpPr>
         <p:spPr>
           <a:xfrm>
-            <a:off x="7699248" y="1399336"/>
+            <a:off x="7699248" y="1545793"/>
             <a:ext cx="59436" cy="59436"/>
           </a:xfrm>
           <a:prstGeom prst="ellipse">
@@ -3692,8 +3692,8 @@
         </p:nvSpPr>
         <p:spPr>
           <a:xfrm>
-            <a:off x="7781544" y="1367332"/>
-            <a:ext cx="4151376" cy="283768"/>
+            <a:off x="7781544" y="1513789"/>
+            <a:ext cx="4151376" cy="430225"/>
           </a:xfrm>
           <a:prstGeom prst="rect">
             <a:avLst/>
@@ -3721,20 +3721,20 @@
       </p:sp>
       <p:sp>
         <p:nvSpPr>
-          <p:cNvPr id="18" name="Oval 17"/>
+          <p:cNvPr id="18" name="Rectangle 17"/>
           <p:cNvSpPr/>
           <p:nvPr/>
         </p:nvSpPr>
         <p:spPr>
           <a:xfrm>
-            <a:off x="7699248" y="1692249"/>
-            <a:ext cx="59436" cy="59436"/>
-          </a:xfrm>
-          <a:prstGeom prst="ellipse">
-            <a:avLst/>
-          </a:prstGeom>
-          <a:solidFill>
-            <a:srgbClr val="38BDF8"/>
+            <a:off x="7498079" y="1945843"/>
+            <a:ext cx="4480560" cy="10972"/>
+          </a:xfrm>
+          <a:prstGeom prst="rect">
+            <a:avLst/>
+          </a:prstGeom>
+          <a:solidFill>
+            <a:srgbClr val="1E3A5F"/>
           </a:solidFill>
           <a:ln>
             <a:noFill/>
@@ -3764,55 +3764,20 @@
       </p:sp>
       <p:sp>
         <p:nvSpPr>
-          <p:cNvPr id="19" name="TextBox 18"/>
-          <p:cNvSpPr txBox="1"/>
-          <p:nvPr/>
-        </p:nvSpPr>
-        <p:spPr>
-          <a:xfrm>
-            <a:off x="7781544" y="1660245"/>
-            <a:ext cx="4151376" cy="283768"/>
+          <p:cNvPr id="19" name="Rectangle 18"/>
+          <p:cNvSpPr/>
+          <p:nvPr/>
+        </p:nvSpPr>
+        <p:spPr>
+          <a:xfrm>
+            <a:off x="7498079" y="1953158"/>
+            <a:ext cx="54864" cy="1148486"/>
           </a:xfrm>
           <a:prstGeom prst="rect">
             <a:avLst/>
           </a:prstGeom>
-          <a:noFill/>
-        </p:spPr>
-        <p:txBody>
-          <a:bodyPr wrap="square" lIns="0" rIns="0" tIns="0" bIns="0">
-            <a:spAutoFit/>
-          </a:bodyPr>
-          <a:lstStyle/>
-          <a:p>
-            <a:pPr algn="l"/>
-            <a:r>
-              <a:rPr sz="750" b="0">
-                <a:solidFill>
-                  <a:srgbClr val="CBD5E1"/>
-                </a:solidFill>
-                <a:latin typeface="Calibri"/>
-              </a:rPr>
-              <a:t>Ten keywords, non-stop, under 1 mW</a:t>
-            </a:r>
-          </a:p>
-        </p:txBody>
-      </p:sp>
-      <p:sp>
-        <p:nvSpPr>
-          <p:cNvPr id="20" name="Rectangle 19"/>
-          <p:cNvSpPr/>
-          <p:nvPr/>
-        </p:nvSpPr>
-        <p:spPr>
-          <a:xfrm>
-            <a:off x="7498079" y="1945843"/>
-            <a:ext cx="4480560" cy="10972"/>
-          </a:xfrm>
-          <a:prstGeom prst="rect">
-            <a:avLst/>
-          </a:prstGeom>
-          <a:solidFill>
-            <a:srgbClr val="1E3A5F"/>
+          <a:solidFill>
+            <a:srgbClr val="2DD4BF"/>
           </a:solidFill>
           <a:ln>
             <a:noFill/>
@@ -3842,20 +3807,20 @@
       </p:sp>
       <p:sp>
         <p:nvSpPr>
-          <p:cNvPr id="21" name="Rectangle 20"/>
+          <p:cNvPr id="20" name="Rectangle 19"/>
           <p:cNvSpPr/>
           <p:nvPr/>
         </p:nvSpPr>
         <p:spPr>
           <a:xfrm>
-            <a:off x="7498079" y="1953158"/>
-            <a:ext cx="54864" cy="1148486"/>
+            <a:off x="7552944" y="1953158"/>
+            <a:ext cx="4425696" cy="256032"/>
           </a:xfrm>
           <a:prstGeom prst="rect">
             <a:avLst/>
           </a:prstGeom>
           <a:solidFill>
-            <a:srgbClr val="2DD4BF"/>
+            <a:srgbClr val="142038"/>
           </a:solidFill>
           <a:ln>
             <a:noFill/>
@@ -3885,20 +3850,20 @@
       </p:sp>
       <p:sp>
         <p:nvSpPr>
-          <p:cNvPr id="22" name="Rectangle 21"/>
+          <p:cNvPr id="21" name="Oval 20"/>
           <p:cNvSpPr/>
           <p:nvPr/>
         </p:nvSpPr>
         <p:spPr>
           <a:xfrm>
-            <a:off x="7552944" y="1953158"/>
-            <a:ext cx="4425696" cy="256032"/>
-          </a:xfrm>
-          <a:prstGeom prst="rect">
-            <a:avLst/>
-          </a:prstGeom>
-          <a:solidFill>
-            <a:srgbClr val="142038"/>
+            <a:off x="7580375" y="1980590"/>
+            <a:ext cx="182880" cy="182880"/>
+          </a:xfrm>
+          <a:prstGeom prst="ellipse">
+            <a:avLst/>
+          </a:prstGeom>
+          <a:solidFill>
+            <a:srgbClr val="2DD4BF"/>
           </a:solidFill>
           <a:ln>
             <a:noFill/>
@@ -3928,50 +3893,7 @@
       </p:sp>
       <p:sp>
         <p:nvSpPr>
-          <p:cNvPr id="23" name="Oval 22"/>
-          <p:cNvSpPr/>
-          <p:nvPr/>
-        </p:nvSpPr>
-        <p:spPr>
-          <a:xfrm>
-            <a:off x="7580375" y="1980590"/>
-            <a:ext cx="182880" cy="182880"/>
-          </a:xfrm>
-          <a:prstGeom prst="ellipse">
-            <a:avLst/>
-          </a:prstGeom>
-          <a:solidFill>
-            <a:srgbClr val="2DD4BF"/>
-          </a:solidFill>
-          <a:ln>
-            <a:noFill/>
-          </a:ln>
-        </p:spPr>
-        <p:style>
-          <a:lnRef idx="1">
-            <a:schemeClr val="accent1"/>
-          </a:lnRef>
-          <a:fillRef idx="3">
-            <a:schemeClr val="accent1"/>
-          </a:fillRef>
-          <a:effectRef idx="2">
-            <a:schemeClr val="accent1"/>
-          </a:effectRef>
-          <a:fontRef idx="minor">
-            <a:schemeClr val="lt1"/>
-          </a:fontRef>
-        </p:style>
-        <p:txBody>
-          <a:bodyPr rtlCol="0" anchor="ctr"/>
-          <a:lstStyle/>
-          <a:p>
-            <a:pPr algn="ctr"/>
-          </a:p>
-        </p:txBody>
-      </p:sp>
-      <p:sp>
-        <p:nvSpPr>
-          <p:cNvPr id="24" name="TextBox 23"/>
+          <p:cNvPr id="22" name="TextBox 21"/>
           <p:cNvSpPr txBox="1"/>
           <p:nvPr/>
         </p:nvSpPr>
@@ -4006,7 +3928,7 @@
       </p:sp>
       <p:sp>
         <p:nvSpPr>
-          <p:cNvPr id="25" name="TextBox 24"/>
+          <p:cNvPr id="23" name="TextBox 22"/>
           <p:cNvSpPr txBox="1"/>
           <p:nvPr/>
         </p:nvSpPr>
@@ -4041,7 +3963,7 @@
       </p:sp>
       <p:sp>
         <p:nvSpPr>
-          <p:cNvPr id="26" name="Rectangle 25"/>
+          <p:cNvPr id="24" name="Rectangle 23"/>
           <p:cNvSpPr/>
           <p:nvPr/>
         </p:nvSpPr>
@@ -4084,7 +4006,7 @@
       </p:sp>
       <p:sp>
         <p:nvSpPr>
-          <p:cNvPr id="27" name="Oval 26"/>
+          <p:cNvPr id="25" name="Oval 24"/>
           <p:cNvSpPr/>
           <p:nvPr/>
         </p:nvSpPr>
@@ -4127,14 +4049,14 @@
       </p:sp>
       <p:sp>
         <p:nvSpPr>
-          <p:cNvPr id="28" name="TextBox 27"/>
+          <p:cNvPr id="26" name="TextBox 25"/>
           <p:cNvSpPr txBox="1"/>
           <p:nvPr/>
         </p:nvSpPr>
         <p:spPr>
           <a:xfrm>
             <a:off x="7781544" y="2222906"/>
-            <a:ext cx="4151376" cy="283768"/>
+            <a:ext cx="4151376" cy="430225"/>
           </a:xfrm>
           <a:prstGeom prst="rect">
             <a:avLst/>
@@ -4162,13 +4084,13 @@
       </p:sp>
       <p:sp>
         <p:nvSpPr>
-          <p:cNvPr id="29" name="Oval 28"/>
+          <p:cNvPr id="27" name="Oval 26"/>
           <p:cNvSpPr/>
           <p:nvPr/>
         </p:nvSpPr>
         <p:spPr>
           <a:xfrm>
-            <a:off x="7699248" y="2547823"/>
+            <a:off x="7699248" y="2694279"/>
             <a:ext cx="59436" cy="59436"/>
           </a:xfrm>
           <a:prstGeom prst="ellipse">
@@ -4205,92 +4127,14 @@
       </p:sp>
       <p:sp>
         <p:nvSpPr>
-          <p:cNvPr id="30" name="TextBox 29"/>
+          <p:cNvPr id="28" name="TextBox 27"/>
           <p:cNvSpPr txBox="1"/>
           <p:nvPr/>
         </p:nvSpPr>
         <p:spPr>
           <a:xfrm>
-            <a:off x="7781544" y="2515819"/>
-            <a:ext cx="4151376" cy="283768"/>
-          </a:xfrm>
-          <a:prstGeom prst="rect">
-            <a:avLst/>
-          </a:prstGeom>
-          <a:noFill/>
-        </p:spPr>
-        <p:txBody>
-          <a:bodyPr wrap="square" lIns="0" rIns="0" tIns="0" bIns="0">
-            <a:spAutoFit/>
-          </a:bodyPr>
-          <a:lstStyle/>
-          <a:p>
-            <a:pPr algn="l"/>
-            <a:r>
-              <a:rPr sz="750" b="0">
-                <a:solidFill>
-                  <a:srgbClr val="CBD5E1"/>
-                </a:solidFill>
-                <a:latin typeface="Calibri"/>
-              </a:rPr>
-              <a:t>Others built specialized chips on ARM processors (Rusci 2020)</a:t>
-            </a:r>
-          </a:p>
-        </p:txBody>
-      </p:sp>
-      <p:sp>
-        <p:nvSpPr>
-          <p:cNvPr id="31" name="Oval 30"/>
-          <p:cNvSpPr/>
-          <p:nvPr/>
-        </p:nvSpPr>
-        <p:spPr>
-          <a:xfrm>
-            <a:off x="7699248" y="2840736"/>
-            <a:ext cx="59436" cy="59436"/>
-          </a:xfrm>
-          <a:prstGeom prst="ellipse">
-            <a:avLst/>
-          </a:prstGeom>
-          <a:solidFill>
-            <a:srgbClr val="2DD4BF"/>
-          </a:solidFill>
-          <a:ln>
-            <a:noFill/>
-          </a:ln>
-        </p:spPr>
-        <p:style>
-          <a:lnRef idx="1">
-            <a:schemeClr val="accent1"/>
-          </a:lnRef>
-          <a:fillRef idx="3">
-            <a:schemeClr val="accent1"/>
-          </a:fillRef>
-          <a:effectRef idx="2">
-            <a:schemeClr val="accent1"/>
-          </a:effectRef>
-          <a:fontRef idx="minor">
-            <a:schemeClr val="lt1"/>
-          </a:fontRef>
-        </p:style>
-        <p:txBody>
-          <a:bodyPr rtlCol="0" anchor="ctr"/>
-          <a:lstStyle/>
-          <a:p>
-            <a:pPr algn="ctr"/>
-          </a:p>
-        </p:txBody>
-      </p:sp>
-      <p:sp>
-        <p:nvSpPr>
-          <p:cNvPr id="32" name="TextBox 31"/>
-          <p:cNvSpPr txBox="1"/>
-          <p:nvPr/>
-        </p:nvSpPr>
-        <p:spPr>
-          <a:xfrm>
-            <a:off x="7781544" y="2808732"/>
-            <a:ext cx="4151376" cy="283768"/>
+            <a:off x="7781544" y="2662275"/>
+            <a:ext cx="4151376" cy="430225"/>
           </a:xfrm>
           <a:prstGeom prst="rect">
             <a:avLst/>
@@ -4318,7 +4162,7 @@
       </p:sp>
       <p:sp>
         <p:nvSpPr>
-          <p:cNvPr id="33" name="Rectangle 32"/>
+          <p:cNvPr id="29" name="Rectangle 28"/>
           <p:cNvSpPr/>
           <p:nvPr/>
         </p:nvSpPr>
@@ -4361,7 +4205,7 @@
       </p:sp>
       <p:sp>
         <p:nvSpPr>
-          <p:cNvPr id="34" name="Rectangle 33"/>
+          <p:cNvPr id="30" name="Rectangle 29"/>
           <p:cNvSpPr/>
           <p:nvPr/>
         </p:nvSpPr>
@@ -4404,7 +4248,7 @@
       </p:sp>
       <p:sp>
         <p:nvSpPr>
-          <p:cNvPr id="35" name="Rectangle 34"/>
+          <p:cNvPr id="31" name="Rectangle 30"/>
           <p:cNvSpPr/>
           <p:nvPr/>
         </p:nvSpPr>
@@ -4447,7 +4291,7 @@
       </p:sp>
       <p:sp>
         <p:nvSpPr>
-          <p:cNvPr id="36" name="Oval 35"/>
+          <p:cNvPr id="32" name="Oval 31"/>
           <p:cNvSpPr/>
           <p:nvPr/>
         </p:nvSpPr>
@@ -4490,7 +4334,7 @@
       </p:sp>
       <p:sp>
         <p:nvSpPr>
-          <p:cNvPr id="37" name="TextBox 36"/>
+          <p:cNvPr id="33" name="TextBox 32"/>
           <p:cNvSpPr txBox="1"/>
           <p:nvPr/>
         </p:nvSpPr>
@@ -4525,7 +4369,7 @@
       </p:sp>
       <p:sp>
         <p:nvSpPr>
-          <p:cNvPr id="38" name="TextBox 37"/>
+          <p:cNvPr id="34" name="TextBox 33"/>
           <p:cNvSpPr txBox="1"/>
           <p:nvPr/>
         </p:nvSpPr>
@@ -4560,7 +4404,7 @@
       </p:sp>
       <p:sp>
         <p:nvSpPr>
-          <p:cNvPr id="39" name="Rectangle 38"/>
+          <p:cNvPr id="35" name="Rectangle 34"/>
           <p:cNvSpPr/>
           <p:nvPr/>
         </p:nvSpPr>
@@ -4603,7 +4447,7 @@
       </p:sp>
       <p:sp>
         <p:nvSpPr>
-          <p:cNvPr id="40" name="Oval 39"/>
+          <p:cNvPr id="36" name="Oval 35"/>
           <p:cNvSpPr/>
           <p:nvPr/>
         </p:nvSpPr>
@@ -4646,14 +4490,14 @@
       </p:sp>
       <p:sp>
         <p:nvSpPr>
-          <p:cNvPr id="41" name="TextBox 40"/>
+          <p:cNvPr id="37" name="TextBox 36"/>
           <p:cNvSpPr txBox="1"/>
           <p:nvPr/>
         </p:nvSpPr>
         <p:spPr>
           <a:xfrm>
             <a:off x="7781544" y="3371392"/>
-            <a:ext cx="4151376" cy="283768"/>
+            <a:ext cx="4151376" cy="430225"/>
           </a:xfrm>
           <a:prstGeom prst="rect">
             <a:avLst/>
@@ -4681,13 +4525,13 @@
       </p:sp>
       <p:sp>
         <p:nvSpPr>
-          <p:cNvPr id="42" name="Oval 41"/>
+          <p:cNvPr id="38" name="Oval 37"/>
           <p:cNvSpPr/>
           <p:nvPr/>
         </p:nvSpPr>
         <p:spPr>
           <a:xfrm>
-            <a:off x="7699248" y="3696309"/>
+            <a:off x="7699248" y="3842765"/>
             <a:ext cx="59436" cy="59436"/>
           </a:xfrm>
           <a:prstGeom prst="ellipse">
@@ -4724,14 +4568,14 @@
       </p:sp>
       <p:sp>
         <p:nvSpPr>
-          <p:cNvPr id="43" name="TextBox 42"/>
+          <p:cNvPr id="39" name="TextBox 38"/>
           <p:cNvSpPr txBox="1"/>
           <p:nvPr/>
         </p:nvSpPr>
         <p:spPr>
           <a:xfrm>
-            <a:off x="7781544" y="3664305"/>
-            <a:ext cx="4151376" cy="283768"/>
+            <a:off x="7781544" y="3810761"/>
+            <a:ext cx="4151376" cy="430225"/>
           </a:xfrm>
           <a:prstGeom prst="rect">
             <a:avLst/>
@@ -4759,20 +4603,20 @@
       </p:sp>
       <p:sp>
         <p:nvSpPr>
-          <p:cNvPr id="44" name="Oval 43"/>
+          <p:cNvPr id="40" name="Rectangle 39"/>
           <p:cNvSpPr/>
           <p:nvPr/>
         </p:nvSpPr>
         <p:spPr>
           <a:xfrm>
-            <a:off x="7699248" y="3989222"/>
-            <a:ext cx="59436" cy="59436"/>
-          </a:xfrm>
-          <a:prstGeom prst="ellipse">
-            <a:avLst/>
-          </a:prstGeom>
-          <a:solidFill>
-            <a:srgbClr val="4ADE80"/>
+            <a:off x="7498079" y="4242816"/>
+            <a:ext cx="4480560" cy="10972"/>
+          </a:xfrm>
+          <a:prstGeom prst="rect">
+            <a:avLst/>
+          </a:prstGeom>
+          <a:solidFill>
+            <a:srgbClr val="1E3A5F"/>
           </a:solidFill>
           <a:ln>
             <a:noFill/>
@@ -4802,55 +4646,20 @@
       </p:sp>
       <p:sp>
         <p:nvSpPr>
-          <p:cNvPr id="45" name="TextBox 44"/>
-          <p:cNvSpPr txBox="1"/>
-          <p:nvPr/>
-        </p:nvSpPr>
-        <p:spPr>
-          <a:xfrm>
-            <a:off x="7781544" y="3957218"/>
-            <a:ext cx="4151376" cy="283768"/>
+          <p:cNvPr id="41" name="Rectangle 40"/>
+          <p:cNvSpPr/>
+          <p:nvPr/>
+        </p:nvSpPr>
+        <p:spPr>
+          <a:xfrm>
+            <a:off x="7498079" y="4250131"/>
+            <a:ext cx="54864" cy="1148486"/>
           </a:xfrm>
           <a:prstGeom prst="rect">
             <a:avLst/>
           </a:prstGeom>
-          <a:noFill/>
-        </p:spPr>
-        <p:txBody>
-          <a:bodyPr wrap="square" lIns="0" rIns="0" tIns="0" bIns="0">
-            <a:spAutoFit/>
-          </a:bodyPr>
-          <a:lstStyle/>
-          <a:p>
-            <a:pPr algn="l"/>
-            <a:r>
-              <a:rPr sz="750" b="0">
-                <a:solidFill>
-                  <a:srgbClr val="CBD5E1"/>
-                </a:solidFill>
-                <a:latin typeface="Calibri"/>
-              </a:rPr>
-              <a:t>Built in SystemVerilog with SPI — plugs into any microcontroller</a:t>
-            </a:r>
-          </a:p>
-        </p:txBody>
-      </p:sp>
-      <p:sp>
-        <p:nvSpPr>
-          <p:cNvPr id="46" name="Rectangle 45"/>
-          <p:cNvSpPr/>
-          <p:nvPr/>
-        </p:nvSpPr>
-        <p:spPr>
-          <a:xfrm>
-            <a:off x="7498079" y="4242816"/>
-            <a:ext cx="4480560" cy="10972"/>
-          </a:xfrm>
-          <a:prstGeom prst="rect">
-            <a:avLst/>
-          </a:prstGeom>
-          <a:solidFill>
-            <a:srgbClr val="1E3A5F"/>
+          <a:solidFill>
+            <a:srgbClr val="FB923C"/>
           </a:solidFill>
           <a:ln>
             <a:noFill/>
@@ -4880,20 +4689,20 @@
       </p:sp>
       <p:sp>
         <p:nvSpPr>
-          <p:cNvPr id="47" name="Rectangle 46"/>
+          <p:cNvPr id="42" name="Rectangle 41"/>
           <p:cNvSpPr/>
           <p:nvPr/>
         </p:nvSpPr>
         <p:spPr>
           <a:xfrm>
-            <a:off x="7498079" y="4250131"/>
-            <a:ext cx="54864" cy="1148486"/>
+            <a:off x="7552944" y="4250131"/>
+            <a:ext cx="4425696" cy="256032"/>
           </a:xfrm>
           <a:prstGeom prst="rect">
             <a:avLst/>
           </a:prstGeom>
           <a:solidFill>
-            <a:srgbClr val="FB923C"/>
+            <a:srgbClr val="142038"/>
           </a:solidFill>
           <a:ln>
             <a:noFill/>
@@ -4923,20 +4732,20 @@
       </p:sp>
       <p:sp>
         <p:nvSpPr>
-          <p:cNvPr id="48" name="Rectangle 47"/>
+          <p:cNvPr id="43" name="Oval 42"/>
           <p:cNvSpPr/>
           <p:nvPr/>
         </p:nvSpPr>
         <p:spPr>
           <a:xfrm>
-            <a:off x="7552944" y="4250131"/>
-            <a:ext cx="4425696" cy="256032"/>
-          </a:xfrm>
-          <a:prstGeom prst="rect">
-            <a:avLst/>
-          </a:prstGeom>
-          <a:solidFill>
-            <a:srgbClr val="142038"/>
+            <a:off x="7580375" y="4277563"/>
+            <a:ext cx="182880" cy="182880"/>
+          </a:xfrm>
+          <a:prstGeom prst="ellipse">
+            <a:avLst/>
+          </a:prstGeom>
+          <a:solidFill>
+            <a:srgbClr val="FB923C"/>
           </a:solidFill>
           <a:ln>
             <a:noFill/>
@@ -4966,50 +4775,7 @@
       </p:sp>
       <p:sp>
         <p:nvSpPr>
-          <p:cNvPr id="49" name="Oval 48"/>
-          <p:cNvSpPr/>
-          <p:nvPr/>
-        </p:nvSpPr>
-        <p:spPr>
-          <a:xfrm>
-            <a:off x="7580375" y="4277563"/>
-            <a:ext cx="182880" cy="182880"/>
-          </a:xfrm>
-          <a:prstGeom prst="ellipse">
-            <a:avLst/>
-          </a:prstGeom>
-          <a:solidFill>
-            <a:srgbClr val="FB923C"/>
-          </a:solidFill>
-          <a:ln>
-            <a:noFill/>
-          </a:ln>
-        </p:spPr>
-        <p:style>
-          <a:lnRef idx="1">
-            <a:schemeClr val="accent1"/>
-          </a:lnRef>
-          <a:fillRef idx="3">
-            <a:schemeClr val="accent1"/>
-          </a:fillRef>
-          <a:effectRef idx="2">
-            <a:schemeClr val="accent1"/>
-          </a:effectRef>
-          <a:fontRef idx="minor">
-            <a:schemeClr val="lt1"/>
-          </a:fontRef>
-        </p:style>
-        <p:txBody>
-          <a:bodyPr rtlCol="0" anchor="ctr"/>
-          <a:lstStyle/>
-          <a:p>
-            <a:pPr algn="ctr"/>
-          </a:p>
-        </p:txBody>
-      </p:sp>
-      <p:sp>
-        <p:nvSpPr>
-          <p:cNvPr id="50" name="TextBox 49"/>
+          <p:cNvPr id="44" name="TextBox 43"/>
           <p:cNvSpPr txBox="1"/>
           <p:nvPr/>
         </p:nvSpPr>
@@ -5044,7 +4810,7 @@
       </p:sp>
       <p:sp>
         <p:nvSpPr>
-          <p:cNvPr id="51" name="TextBox 50"/>
+          <p:cNvPr id="45" name="TextBox 44"/>
           <p:cNvSpPr txBox="1"/>
           <p:nvPr/>
         </p:nvSpPr>
@@ -5079,7 +4845,7 @@
       </p:sp>
       <p:sp>
         <p:nvSpPr>
-          <p:cNvPr id="52" name="Rectangle 51"/>
+          <p:cNvPr id="46" name="Rectangle 45"/>
           <p:cNvSpPr/>
           <p:nvPr/>
         </p:nvSpPr>
@@ -5122,7 +4888,7 @@
       </p:sp>
       <p:sp>
         <p:nvSpPr>
-          <p:cNvPr id="53" name="Oval 52"/>
+          <p:cNvPr id="47" name="Oval 46"/>
           <p:cNvSpPr/>
           <p:nvPr/>
         </p:nvSpPr>
@@ -5165,14 +4931,14 @@
       </p:sp>
       <p:sp>
         <p:nvSpPr>
-          <p:cNvPr id="54" name="TextBox 53"/>
+          <p:cNvPr id="48" name="TextBox 47"/>
           <p:cNvSpPr txBox="1"/>
           <p:nvPr/>
         </p:nvSpPr>
         <p:spPr>
           <a:xfrm>
             <a:off x="7781544" y="4519879"/>
-            <a:ext cx="4151376" cy="283768"/>
+            <a:ext cx="4151376" cy="430225"/>
           </a:xfrm>
           <a:prstGeom prst="rect">
             <a:avLst/>
@@ -5193,20 +4959,20 @@
                 </a:solidFill>
                 <a:latin typeface="Calibri"/>
               </a:rPr>
-              <a:t>SW baseline: 0.44 ms/inference, bottlenecked by memory — confirmed</a:t>
-            </a:r>
-          </a:p>
-        </p:txBody>
-      </p:sp>
-      <p:sp>
-        <p:nvSpPr>
-          <p:cNvPr id="55" name="Oval 54"/>
+              <a:t>SW: 0.44 ms/inference, confirmed bottlenecked by memory</a:t>
+            </a:r>
+          </a:p>
+        </p:txBody>
+      </p:sp>
+      <p:sp>
+        <p:nvSpPr>
+          <p:cNvPr id="49" name="Oval 48"/>
           <p:cNvSpPr/>
           <p:nvPr/>
         </p:nvSpPr>
         <p:spPr>
           <a:xfrm>
-            <a:off x="7699248" y="4844796"/>
+            <a:off x="7699248" y="4991252"/>
             <a:ext cx="59436" cy="59436"/>
           </a:xfrm>
           <a:prstGeom prst="ellipse">
@@ -5243,14 +5009,14 @@
       </p:sp>
       <p:sp>
         <p:nvSpPr>
-          <p:cNvPr id="56" name="TextBox 55"/>
+          <p:cNvPr id="50" name="TextBox 49"/>
           <p:cNvSpPr txBox="1"/>
           <p:nvPr/>
         </p:nvSpPr>
         <p:spPr>
           <a:xfrm>
-            <a:off x="7781544" y="4812791"/>
-            <a:ext cx="4151376" cy="283768"/>
+            <a:off x="7781544" y="4959248"/>
+            <a:ext cx="4151376" cy="430225"/>
           </a:xfrm>
           <a:prstGeom prst="rect">
             <a:avLst/>
@@ -5278,20 +5044,20 @@
       </p:sp>
       <p:sp>
         <p:nvSpPr>
-          <p:cNvPr id="57" name="Oval 56"/>
+          <p:cNvPr id="51" name="Rectangle 50"/>
           <p:cNvSpPr/>
           <p:nvPr/>
         </p:nvSpPr>
         <p:spPr>
           <a:xfrm>
-            <a:off x="7699248" y="5137708"/>
-            <a:ext cx="59436" cy="59436"/>
-          </a:xfrm>
-          <a:prstGeom prst="ellipse">
-            <a:avLst/>
-          </a:prstGeom>
-          <a:solidFill>
-            <a:srgbClr val="FB923C"/>
+            <a:off x="7498079" y="5391302"/>
+            <a:ext cx="4480560" cy="10972"/>
+          </a:xfrm>
+          <a:prstGeom prst="rect">
+            <a:avLst/>
+          </a:prstGeom>
+          <a:solidFill>
+            <a:srgbClr val="1E3A5F"/>
           </a:solidFill>
           <a:ln>
             <a:noFill/>
@@ -5321,55 +5087,20 @@
       </p:sp>
       <p:sp>
         <p:nvSpPr>
-          <p:cNvPr id="58" name="TextBox 57"/>
-          <p:cNvSpPr txBox="1"/>
-          <p:nvPr/>
-        </p:nvSpPr>
-        <p:spPr>
-          <a:xfrm>
-            <a:off x="7781544" y="5105704"/>
-            <a:ext cx="4151376" cy="283768"/>
+          <p:cNvPr id="52" name="Rectangle 51"/>
+          <p:cNvSpPr/>
+          <p:nvPr/>
+        </p:nvSpPr>
+        <p:spPr>
+          <a:xfrm>
+            <a:off x="7498079" y="5398617"/>
+            <a:ext cx="54864" cy="1148486"/>
           </a:xfrm>
           <a:prstGeom prst="rect">
             <a:avLst/>
           </a:prstGeom>
-          <a:noFill/>
-        </p:spPr>
-        <p:txBody>
-          <a:bodyPr wrap="square" lIns="0" rIns="0" tIns="0" bIns="0">
-            <a:spAutoFit/>
-          </a:bodyPr>
-          <a:lstStyle/>
-          <a:p>
-            <a:pPr algn="l"/>
-            <a:r>
-              <a:rPr sz="750" b="0">
-                <a:solidFill>
-                  <a:srgbClr val="CBD5E1"/>
-                </a:solidFill>
-                <a:latin typeface="Calibri"/>
-              </a:rPr>
-              <a:t>All 4 outputs match expected values; SPI read &amp; write pass</a:t>
-            </a:r>
-          </a:p>
-        </p:txBody>
-      </p:sp>
-      <p:sp>
-        <p:nvSpPr>
-          <p:cNvPr id="59" name="Rectangle 58"/>
-          <p:cNvSpPr/>
-          <p:nvPr/>
-        </p:nvSpPr>
-        <p:spPr>
-          <a:xfrm>
-            <a:off x="7498079" y="5391302"/>
-            <a:ext cx="4480560" cy="10972"/>
-          </a:xfrm>
-          <a:prstGeom prst="rect">
-            <a:avLst/>
-          </a:prstGeom>
-          <a:solidFill>
-            <a:srgbClr val="1E3A5F"/>
+          <a:solidFill>
+            <a:srgbClr val="F87171"/>
           </a:solidFill>
           <a:ln>
             <a:noFill/>
@@ -5399,20 +5130,20 @@
       </p:sp>
       <p:sp>
         <p:nvSpPr>
-          <p:cNvPr id="60" name="Rectangle 59"/>
+          <p:cNvPr id="53" name="Rectangle 52"/>
           <p:cNvSpPr/>
           <p:nvPr/>
         </p:nvSpPr>
         <p:spPr>
           <a:xfrm>
-            <a:off x="7498079" y="5398617"/>
-            <a:ext cx="54864" cy="1148486"/>
+            <a:off x="7552944" y="5398617"/>
+            <a:ext cx="4425696" cy="256032"/>
           </a:xfrm>
           <a:prstGeom prst="rect">
             <a:avLst/>
           </a:prstGeom>
           <a:solidFill>
-            <a:srgbClr val="F87171"/>
+            <a:srgbClr val="142038"/>
           </a:solidFill>
           <a:ln>
             <a:noFill/>
@@ -5442,20 +5173,20 @@
       </p:sp>
       <p:sp>
         <p:nvSpPr>
-          <p:cNvPr id="61" name="Rectangle 60"/>
+          <p:cNvPr id="54" name="Oval 53"/>
           <p:cNvSpPr/>
           <p:nvPr/>
         </p:nvSpPr>
         <p:spPr>
           <a:xfrm>
-            <a:off x="7552944" y="5398617"/>
-            <a:ext cx="4425696" cy="256032"/>
-          </a:xfrm>
-          <a:prstGeom prst="rect">
-            <a:avLst/>
-          </a:prstGeom>
-          <a:solidFill>
-            <a:srgbClr val="142038"/>
+            <a:off x="7580375" y="5426049"/>
+            <a:ext cx="182880" cy="182880"/>
+          </a:xfrm>
+          <a:prstGeom prst="ellipse">
+            <a:avLst/>
+          </a:prstGeom>
+          <a:solidFill>
+            <a:srgbClr val="F87171"/>
           </a:solidFill>
           <a:ln>
             <a:noFill/>
@@ -5485,50 +5216,7 @@
       </p:sp>
       <p:sp>
         <p:nvSpPr>
-          <p:cNvPr id="62" name="Oval 61"/>
-          <p:cNvSpPr/>
-          <p:nvPr/>
-        </p:nvSpPr>
-        <p:spPr>
-          <a:xfrm>
-            <a:off x="7580375" y="5426049"/>
-            <a:ext cx="182880" cy="182880"/>
-          </a:xfrm>
-          <a:prstGeom prst="ellipse">
-            <a:avLst/>
-          </a:prstGeom>
-          <a:solidFill>
-            <a:srgbClr val="F87171"/>
-          </a:solidFill>
-          <a:ln>
-            <a:noFill/>
-          </a:ln>
-        </p:spPr>
-        <p:style>
-          <a:lnRef idx="1">
-            <a:schemeClr val="accent1"/>
-          </a:lnRef>
-          <a:fillRef idx="3">
-            <a:schemeClr val="accent1"/>
-          </a:fillRef>
-          <a:effectRef idx="2">
-            <a:schemeClr val="accent1"/>
-          </a:effectRef>
-          <a:fontRef idx="minor">
-            <a:schemeClr val="lt1"/>
-          </a:fontRef>
-        </p:style>
-        <p:txBody>
-          <a:bodyPr rtlCol="0" anchor="ctr"/>
-          <a:lstStyle/>
-          <a:p>
-            <a:pPr algn="ctr"/>
-          </a:p>
-        </p:txBody>
-      </p:sp>
-      <p:sp>
-        <p:nvSpPr>
-          <p:cNvPr id="63" name="TextBox 62"/>
+          <p:cNvPr id="55" name="TextBox 54"/>
           <p:cNvSpPr txBox="1"/>
           <p:nvPr/>
         </p:nvSpPr>
@@ -5563,7 +5251,7 @@
       </p:sp>
       <p:sp>
         <p:nvSpPr>
-          <p:cNvPr id="64" name="TextBox 63"/>
+          <p:cNvPr id="56" name="TextBox 55"/>
           <p:cNvSpPr txBox="1"/>
           <p:nvPr/>
         </p:nvSpPr>
@@ -5598,7 +5286,7 @@
       </p:sp>
       <p:sp>
         <p:nvSpPr>
-          <p:cNvPr id="65" name="Rectangle 64"/>
+          <p:cNvPr id="57" name="Rectangle 56"/>
           <p:cNvSpPr/>
           <p:nvPr/>
         </p:nvSpPr>
@@ -5641,7 +5329,7 @@
       </p:sp>
       <p:sp>
         <p:nvSpPr>
-          <p:cNvPr id="66" name="Oval 65"/>
+          <p:cNvPr id="58" name="Oval 57"/>
           <p:cNvSpPr/>
           <p:nvPr/>
         </p:nvSpPr>
@@ -5684,14 +5372,14 @@
       </p:sp>
       <p:sp>
         <p:nvSpPr>
-          <p:cNvPr id="67" name="TextBox 66"/>
+          <p:cNvPr id="59" name="TextBox 58"/>
           <p:cNvSpPr txBox="1"/>
           <p:nvPr/>
         </p:nvSpPr>
         <p:spPr>
           <a:xfrm>
             <a:off x="7781544" y="5668365"/>
-            <a:ext cx="4151376" cy="283768"/>
+            <a:ext cx="4151376" cy="430225"/>
           </a:xfrm>
           <a:prstGeom prst="rect">
             <a:avLst/>
@@ -5712,20 +5400,20 @@
                 </a:solidFill>
                 <a:latin typeface="Calibri"/>
               </a:rPr>
-              <a:t>Run synthesis to get real chip area, power &amp; speed numbers</a:t>
-            </a:r>
-          </a:p>
-        </p:txBody>
-      </p:sp>
-      <p:sp>
-        <p:nvSpPr>
-          <p:cNvPr id="68" name="Oval 67"/>
+              <a:t>Run synthesis → real chip area, power &amp; speed numbers</a:t>
+            </a:r>
+          </a:p>
+        </p:txBody>
+      </p:sp>
+      <p:sp>
+        <p:nvSpPr>
+          <p:cNvPr id="60" name="Oval 59"/>
           <p:cNvSpPr/>
           <p:nvPr/>
         </p:nvSpPr>
         <p:spPr>
           <a:xfrm>
-            <a:off x="7699248" y="5993282"/>
+            <a:off x="7699248" y="6139738"/>
             <a:ext cx="59436" cy="59436"/>
           </a:xfrm>
           <a:prstGeom prst="ellipse">
@@ -5762,14 +5450,14 @@
       </p:sp>
       <p:sp>
         <p:nvSpPr>
-          <p:cNvPr id="69" name="TextBox 68"/>
+          <p:cNvPr id="61" name="TextBox 60"/>
           <p:cNvSpPr txBox="1"/>
           <p:nvPr/>
         </p:nvSpPr>
         <p:spPr>
           <a:xfrm>
-            <a:off x="7781544" y="5961278"/>
-            <a:ext cx="4151376" cy="283768"/>
+            <a:off x="7781544" y="6107734"/>
+            <a:ext cx="4151376" cy="430225"/>
           </a:xfrm>
           <a:prstGeom prst="rect">
             <a:avLst/>
@@ -5790,27 +5478,27 @@
                 </a:solidFill>
                 <a:latin typeface="Calibri"/>
               </a:rPr>
-              <a:t>Compare HW vs SW performance — target more than 100× faster</a:t>
-            </a:r>
-          </a:p>
-        </p:txBody>
-      </p:sp>
-      <p:sp>
-        <p:nvSpPr>
-          <p:cNvPr id="70" name="Oval 69"/>
+              <a:t>Compare HW vs SW — target more than 100× faster</a:t>
+            </a:r>
+          </a:p>
+        </p:txBody>
+      </p:sp>
+      <p:sp>
+        <p:nvSpPr>
+          <p:cNvPr id="62" name="Rectangle 61"/>
           <p:cNvSpPr/>
           <p:nvPr/>
         </p:nvSpPr>
         <p:spPr>
           <a:xfrm>
-            <a:off x="7699248" y="6286195"/>
-            <a:ext cx="59436" cy="59436"/>
-          </a:xfrm>
-          <a:prstGeom prst="ellipse">
-            <a:avLst/>
-          </a:prstGeom>
-          <a:solidFill>
-            <a:srgbClr val="F87171"/>
+            <a:off x="0" y="6547104"/>
+            <a:ext cx="12161520" cy="310896"/>
+          </a:xfrm>
+          <a:prstGeom prst="rect">
+            <a:avLst/>
+          </a:prstGeom>
+          <a:solidFill>
+            <a:srgbClr val="0F2147"/>
           </a:solidFill>
           <a:ln>
             <a:noFill/>
@@ -5840,85 +5528,7 @@
       </p:sp>
       <p:sp>
         <p:nvSpPr>
-          <p:cNvPr id="71" name="TextBox 70"/>
-          <p:cNvSpPr txBox="1"/>
-          <p:nvPr/>
-        </p:nvSpPr>
-        <p:spPr>
-          <a:xfrm>
-            <a:off x="7781544" y="6254191"/>
-            <a:ext cx="4151376" cy="283768"/>
-          </a:xfrm>
-          <a:prstGeom prst="rect">
-            <a:avLst/>
-          </a:prstGeom>
-          <a:noFill/>
-        </p:spPr>
-        <p:txBody>
-          <a:bodyPr wrap="square" lIns="0" rIns="0" tIns="0" bIns="0">
-            <a:spAutoFit/>
-          </a:bodyPr>
-          <a:lstStyle/>
-          <a:p>
-            <a:pPr algn="l"/>
-            <a:r>
-              <a:rPr sz="750" b="0">
-                <a:solidFill>
-                  <a:srgbClr val="CBD5E1"/>
-                </a:solidFill>
-                <a:latin typeface="Calibri"/>
-              </a:rPr>
-              <a:t>Success: synthesizable design, ≥92% accuracy, under 1 mW</a:t>
-            </a:r>
-          </a:p>
-        </p:txBody>
-      </p:sp>
-      <p:sp>
-        <p:nvSpPr>
-          <p:cNvPr id="72" name="Rectangle 71"/>
-          <p:cNvSpPr/>
-          <p:nvPr/>
-        </p:nvSpPr>
-        <p:spPr>
-          <a:xfrm>
-            <a:off x="0" y="6547104"/>
-            <a:ext cx="12161520" cy="310896"/>
-          </a:xfrm>
-          <a:prstGeom prst="rect">
-            <a:avLst/>
-          </a:prstGeom>
-          <a:solidFill>
-            <a:srgbClr val="0F2147"/>
-          </a:solidFill>
-          <a:ln>
-            <a:noFill/>
-          </a:ln>
-        </p:spPr>
-        <p:style>
-          <a:lnRef idx="1">
-            <a:schemeClr val="accent1"/>
-          </a:lnRef>
-          <a:fillRef idx="3">
-            <a:schemeClr val="accent1"/>
-          </a:fillRef>
-          <a:effectRef idx="2">
-            <a:schemeClr val="accent1"/>
-          </a:effectRef>
-          <a:fontRef idx="minor">
-            <a:schemeClr val="lt1"/>
-          </a:fontRef>
-        </p:style>
-        <p:txBody>
-          <a:bodyPr rtlCol="0" anchor="ctr"/>
-          <a:lstStyle/>
-          <a:p>
-            <a:pPr algn="ctr"/>
-          </a:p>
-        </p:txBody>
-      </p:sp>
-      <p:sp>
-        <p:nvSpPr>
-          <p:cNvPr id="73" name="TextBox 72"/>
+          <p:cNvPr id="63" name="TextBox 62"/>
           <p:cNvSpPr txBox="1"/>
           <p:nvPr/>
         </p:nvSpPr>

</xml_diff>